<commit_message>
use case description update
</commit_message>
<xml_diff>
--- a/spec/additionalDocumentation/AutomationArchitecture/diagrams/260623 Example FW update.pptx
+++ b/spec/additionalDocumentation/AutomationArchitecture/diagrams/260623 Example FW update.pptx
@@ -495,7 +495,7 @@
           <a:p>
             <a:fld id="{96DA8C75-A467-416A-B374-E97E5CF82461}" type="datetimeFigureOut">
               <a:rPr lang="de-DE" smtClean="0"/>
-              <a:t>02.07.2026</a:t>
+              <a:t>23.07.2026</a:t>
             </a:fld>
             <a:endParaRPr lang="de-DE"/>
           </a:p>
@@ -693,7 +693,7 @@
           <a:p>
             <a:fld id="{96DA8C75-A467-416A-B374-E97E5CF82461}" type="datetimeFigureOut">
               <a:rPr lang="de-DE" smtClean="0"/>
-              <a:t>02.07.2026</a:t>
+              <a:t>23.07.2026</a:t>
             </a:fld>
             <a:endParaRPr lang="de-DE"/>
           </a:p>
@@ -901,7 +901,7 @@
           <a:p>
             <a:fld id="{96DA8C75-A467-416A-B374-E97E5CF82461}" type="datetimeFigureOut">
               <a:rPr lang="de-DE" smtClean="0"/>
-              <a:t>02.07.2026</a:t>
+              <a:t>23.07.2026</a:t>
             </a:fld>
             <a:endParaRPr lang="de-DE"/>
           </a:p>
@@ -1099,7 +1099,7 @@
           <a:p>
             <a:fld id="{96DA8C75-A467-416A-B374-E97E5CF82461}" type="datetimeFigureOut">
               <a:rPr lang="de-DE" smtClean="0"/>
-              <a:t>02.07.2026</a:t>
+              <a:t>23.07.2026</a:t>
             </a:fld>
             <a:endParaRPr lang="de-DE"/>
           </a:p>
@@ -1374,7 +1374,7 @@
           <a:p>
             <a:fld id="{96DA8C75-A467-416A-B374-E97E5CF82461}" type="datetimeFigureOut">
               <a:rPr lang="de-DE" smtClean="0"/>
-              <a:t>02.07.2026</a:t>
+              <a:t>23.07.2026</a:t>
             </a:fld>
             <a:endParaRPr lang="de-DE"/>
           </a:p>
@@ -1639,7 +1639,7 @@
           <a:p>
             <a:fld id="{96DA8C75-A467-416A-B374-E97E5CF82461}" type="datetimeFigureOut">
               <a:rPr lang="de-DE" smtClean="0"/>
-              <a:t>02.07.2026</a:t>
+              <a:t>23.07.2026</a:t>
             </a:fld>
             <a:endParaRPr lang="de-DE"/>
           </a:p>
@@ -2051,7 +2051,7 @@
           <a:p>
             <a:fld id="{96DA8C75-A467-416A-B374-E97E5CF82461}" type="datetimeFigureOut">
               <a:rPr lang="de-DE" smtClean="0"/>
-              <a:t>02.07.2026</a:t>
+              <a:t>23.07.2026</a:t>
             </a:fld>
             <a:endParaRPr lang="de-DE"/>
           </a:p>
@@ -2192,7 +2192,7 @@
           <a:p>
             <a:fld id="{96DA8C75-A467-416A-B374-E97E5CF82461}" type="datetimeFigureOut">
               <a:rPr lang="de-DE" smtClean="0"/>
-              <a:t>02.07.2026</a:t>
+              <a:t>23.07.2026</a:t>
             </a:fld>
             <a:endParaRPr lang="de-DE"/>
           </a:p>
@@ -2305,7 +2305,7 @@
           <a:p>
             <a:fld id="{96DA8C75-A467-416A-B374-E97E5CF82461}" type="datetimeFigureOut">
               <a:rPr lang="de-DE" smtClean="0"/>
-              <a:t>02.07.2026</a:t>
+              <a:t>23.07.2026</a:t>
             </a:fld>
             <a:endParaRPr lang="de-DE"/>
           </a:p>
@@ -2616,7 +2616,7 @@
           <a:p>
             <a:fld id="{96DA8C75-A467-416A-B374-E97E5CF82461}" type="datetimeFigureOut">
               <a:rPr lang="de-DE" smtClean="0"/>
-              <a:t>02.07.2026</a:t>
+              <a:t>23.07.2026</a:t>
             </a:fld>
             <a:endParaRPr lang="de-DE"/>
           </a:p>
@@ -2904,7 +2904,7 @@
           <a:p>
             <a:fld id="{96DA8C75-A467-416A-B374-E97E5CF82461}" type="datetimeFigureOut">
               <a:rPr lang="de-DE" smtClean="0"/>
-              <a:t>02.07.2026</a:t>
+              <a:t>23.07.2026</a:t>
             </a:fld>
             <a:endParaRPr lang="de-DE"/>
           </a:p>
@@ -3148,7 +3148,7 @@
           <a:p>
             <a:fld id="{96DA8C75-A467-416A-B374-E97E5CF82461}" type="datetimeFigureOut">
               <a:rPr lang="de-DE" smtClean="0"/>
-              <a:t>02.07.2026</a:t>
+              <a:t>23.07.2026</a:t>
             </a:fld>
             <a:endParaRPr lang="de-DE"/>
           </a:p>
@@ -4435,7 +4435,7 @@
             <a:avLst/>
           </a:prstGeom>
           <a:solidFill>
-            <a:srgbClr val="FFFF00"/>
+            <a:srgbClr val="FFFF97"/>
           </a:solidFill>
           <a:ln>
             <a:solidFill>
@@ -5320,7 +5320,7 @@
             <a:avLst/>
           </a:prstGeom>
           <a:solidFill>
-            <a:srgbClr val="FFFF00"/>
+            <a:srgbClr val="FFFF97"/>
           </a:solidFill>
           <a:ln>
             <a:solidFill>
@@ -6594,7 +6594,7 @@
             <a:avLst/>
           </a:prstGeom>
           <a:solidFill>
-            <a:srgbClr val="FFFF00"/>
+            <a:srgbClr val="FFFF97"/>
           </a:solidFill>
           <a:ln>
             <a:solidFill>
@@ -7964,14 +7964,14 @@
         </p:nvSpPr>
         <p:spPr>
           <a:xfrm>
-            <a:off x="1959932" y="968608"/>
+            <a:off x="1921832" y="976228"/>
             <a:ext cx="2691267" cy="1772098"/>
           </a:xfrm>
           <a:prstGeom prst="rect">
             <a:avLst/>
           </a:prstGeom>
           <a:solidFill>
-            <a:srgbClr val="FFFF00"/>
+            <a:srgbClr val="FFFF97"/>
           </a:solidFill>
           <a:ln>
             <a:solidFill>
@@ -8023,7 +8023,7 @@
         </p:nvSpPr>
         <p:spPr>
           <a:xfrm>
-            <a:off x="4401124" y="2072241"/>
+            <a:off x="4363024" y="2079861"/>
             <a:ext cx="1534230" cy="570807"/>
           </a:xfrm>
           <a:prstGeom prst="can">
@@ -8075,7 +8075,7 @@
         </p:nvSpPr>
         <p:spPr>
           <a:xfrm>
-            <a:off x="2835855" y="3137674"/>
+            <a:off x="2797755" y="3145294"/>
             <a:ext cx="1609724" cy="1303020"/>
           </a:xfrm>
           <a:prstGeom prst="verticalScroll">
@@ -8159,7 +8159,7 @@
         </p:nvSpPr>
         <p:spPr>
           <a:xfrm>
-            <a:off x="2130034" y="1223111"/>
+            <a:off x="2091934" y="1230731"/>
             <a:ext cx="2237448" cy="184666"/>
           </a:xfrm>
           <a:prstGeom prst="rect">
@@ -8194,7 +8194,7 @@
         </p:nvSpPr>
         <p:spPr>
           <a:xfrm>
-            <a:off x="2710249" y="1887033"/>
+            <a:off x="2672149" y="1894653"/>
             <a:ext cx="638710" cy="419100"/>
           </a:xfrm>
           <a:prstGeom prst="rect">
@@ -8244,7 +8244,7 @@
         </p:nvSpPr>
         <p:spPr>
           <a:xfrm>
-            <a:off x="2901007" y="2140916"/>
+            <a:off x="2862907" y="2148536"/>
             <a:ext cx="638710" cy="419100"/>
           </a:xfrm>
           <a:prstGeom prst="rect">
@@ -8294,7 +8294,7 @@
         </p:nvSpPr>
         <p:spPr>
           <a:xfrm>
-            <a:off x="3506326" y="2226302"/>
+            <a:off x="3468226" y="2233922"/>
             <a:ext cx="638710" cy="419100"/>
           </a:xfrm>
           <a:prstGeom prst="rect">
@@ -8344,7 +8344,7 @@
         </p:nvSpPr>
         <p:spPr>
           <a:xfrm>
-            <a:off x="583723" y="2107215"/>
+            <a:off x="545623" y="2114835"/>
             <a:ext cx="1534230" cy="570807"/>
           </a:xfrm>
           <a:prstGeom prst="can">
@@ -8397,7 +8397,7 @@
         </p:nvSpPr>
         <p:spPr>
           <a:xfrm>
-            <a:off x="3243858" y="1259521"/>
+            <a:off x="3205758" y="1267141"/>
             <a:ext cx="638710" cy="419100"/>
           </a:xfrm>
           <a:prstGeom prst="rect">
@@ -8450,7 +8450,7 @@
         </p:nvSpPr>
         <p:spPr>
           <a:xfrm>
-            <a:off x="103302" y="3043901"/>
+            <a:off x="65202" y="3051521"/>
             <a:ext cx="3199108" cy="2492990"/>
           </a:xfrm>
           <a:prstGeom prst="rect">
@@ -8605,7 +8605,7 @@
         </p:nvSpPr>
         <p:spPr>
           <a:xfrm>
-            <a:off x="5935125" y="860720"/>
+            <a:off x="5897025" y="868340"/>
             <a:ext cx="3199108" cy="2492990"/>
           </a:xfrm>
           <a:prstGeom prst="rect">
@@ -8760,7 +8760,7 @@
         </p:nvSpPr>
         <p:spPr>
           <a:xfrm>
-            <a:off x="4335571" y="3886841"/>
+            <a:off x="4297471" y="3894461"/>
             <a:ext cx="3199108" cy="2492990"/>
           </a:xfrm>
           <a:prstGeom prst="rect">
@@ -8867,7 +8867,7 @@
         </p:nvSpPr>
         <p:spPr>
           <a:xfrm>
-            <a:off x="1033125" y="500929"/>
+            <a:off x="995025" y="508549"/>
             <a:ext cx="638710" cy="419100"/>
           </a:xfrm>
           <a:prstGeom prst="rect">
@@ -8929,7 +8929,7 @@
         </p:blipFill>
         <p:spPr>
           <a:xfrm>
-            <a:off x="1094259" y="565351"/>
+            <a:off x="1056159" y="572971"/>
             <a:ext cx="166165" cy="174914"/>
           </a:xfrm>
           <a:prstGeom prst="rect">
@@ -8955,7 +8955,7 @@
         </p:nvCxnSpPr>
         <p:spPr>
           <a:xfrm rot="16200000" flipH="1">
-            <a:off x="2288100" y="-15592"/>
+            <a:off x="2250000" y="-7972"/>
             <a:ext cx="339492" cy="2210733"/>
           </a:xfrm>
           <a:prstGeom prst="curvedConnector3">
@@ -9003,7 +9003,7 @@
         </p:nvCxnSpPr>
         <p:spPr>
           <a:xfrm rot="16200000" flipH="1">
-            <a:off x="3452169" y="1789664"/>
+            <a:off x="3414069" y="1797284"/>
             <a:ext cx="293798" cy="71711"/>
           </a:xfrm>
           <a:prstGeom prst="curvedConnector3">
@@ -9051,7 +9051,7 @@
         </p:nvCxnSpPr>
         <p:spPr>
           <a:xfrm flipV="1">
-            <a:off x="2117953" y="2181969"/>
+            <a:off x="2079853" y="2189589"/>
             <a:ext cx="1197616" cy="210650"/>
           </a:xfrm>
           <a:prstGeom prst="curvedConnector3">
@@ -9100,7 +9100,7 @@
         </p:nvCxnSpPr>
         <p:spPr>
           <a:xfrm rot="10800000">
-            <a:off x="1350839" y="2107215"/>
+            <a:off x="1312739" y="2114835"/>
             <a:ext cx="1964731" cy="74754"/>
           </a:xfrm>
           <a:prstGeom prst="curvedConnector4">
@@ -9145,7 +9145,7 @@
         </p:nvSpPr>
         <p:spPr>
           <a:xfrm>
-            <a:off x="3315569" y="1972419"/>
+            <a:off x="3277469" y="1980039"/>
             <a:ext cx="638710" cy="419100"/>
           </a:xfrm>
           <a:prstGeom prst="rect">
@@ -9201,7 +9201,7 @@
         </p:nvCxnSpPr>
         <p:spPr>
           <a:xfrm rot="10800000">
-            <a:off x="3954278" y="2173317"/>
+            <a:off x="3916178" y="2180937"/>
             <a:ext cx="446846" cy="184328"/>
           </a:xfrm>
           <a:prstGeom prst="curvedConnector3">
@@ -9250,7 +9250,7 @@
         </p:nvCxnSpPr>
         <p:spPr>
           <a:xfrm flipV="1">
-            <a:off x="3954279" y="2072241"/>
+            <a:off x="3916179" y="2079861"/>
             <a:ext cx="1213960" cy="109728"/>
           </a:xfrm>
           <a:prstGeom prst="curvedConnector4">
@@ -9298,7 +9298,7 @@
         </p:nvCxnSpPr>
         <p:spPr>
           <a:xfrm rot="16200000" flipH="1">
-            <a:off x="3408036" y="2618407"/>
+            <a:off x="3369936" y="2626027"/>
             <a:ext cx="746155" cy="292378"/>
           </a:xfrm>
           <a:prstGeom prst="curvedConnector3">
@@ -9342,7 +9342,7 @@
         </p:nvCxnSpPr>
         <p:spPr>
           <a:xfrm>
-            <a:off x="8887432" y="3898363"/>
+            <a:off x="8849332" y="3905983"/>
             <a:ext cx="3304568" cy="1468092"/>
           </a:xfrm>
           <a:prstGeom prst="bentConnector3">
@@ -9390,7 +9390,7 @@
         </p:nvCxnSpPr>
         <p:spPr>
           <a:xfrm>
-            <a:off x="8887432" y="3807202"/>
+            <a:off x="8849332" y="3814822"/>
             <a:ext cx="3304568" cy="1559253"/>
           </a:xfrm>
           <a:prstGeom prst="bentConnector3">
@@ -9439,7 +9439,7 @@
         </p:nvCxnSpPr>
         <p:spPr>
           <a:xfrm rot="10800000" flipH="1" flipV="1">
-            <a:off x="4282702" y="3789183"/>
+            <a:off x="4244602" y="3796803"/>
             <a:ext cx="4604730" cy="524235"/>
           </a:xfrm>
           <a:prstGeom prst="curvedConnector5">
@@ -9485,7 +9485,7 @@
         </p:nvSpPr>
         <p:spPr>
           <a:xfrm>
-            <a:off x="5841193" y="3621364"/>
+            <a:off x="5803093" y="3628984"/>
             <a:ext cx="1998928" cy="276999"/>
           </a:xfrm>
           <a:prstGeom prst="rect">
@@ -9521,7 +9521,7 @@
         </p:nvSpPr>
         <p:spPr>
           <a:xfrm>
-            <a:off x="9904032" y="4399667"/>
+            <a:off x="9865932" y="4407287"/>
             <a:ext cx="1437623" cy="374321"/>
           </a:xfrm>
           <a:prstGeom prst="roundRect">
@@ -9968,7 +9968,7 @@
             <a:avLst/>
           </a:prstGeom>
           <a:solidFill>
-            <a:srgbClr val="FFFF00"/>
+            <a:srgbClr val="FFFF97"/>
           </a:solidFill>
           <a:ln>
             <a:solidFill>
@@ -10935,7 +10935,7 @@
             <a:avLst/>
           </a:prstGeom>
           <a:solidFill>
-            <a:srgbClr val="FFFF00"/>
+            <a:srgbClr val="FFFF97"/>
           </a:solidFill>
           <a:ln>
             <a:solidFill>
@@ -12353,14 +12353,14 @@
         </p:nvSpPr>
         <p:spPr>
           <a:xfrm>
-            <a:off x="1959932" y="968608"/>
+            <a:off x="1921832" y="968608"/>
             <a:ext cx="2691267" cy="1772098"/>
           </a:xfrm>
           <a:prstGeom prst="rect">
             <a:avLst/>
           </a:prstGeom>
           <a:solidFill>
-            <a:srgbClr val="FFFF00"/>
+            <a:srgbClr val="FFFF97"/>
           </a:solidFill>
           <a:ln>
             <a:solidFill>
@@ -12412,7 +12412,7 @@
         </p:nvSpPr>
         <p:spPr>
           <a:xfrm>
-            <a:off x="4401124" y="2072241"/>
+            <a:off x="4363024" y="2072241"/>
             <a:ext cx="1534230" cy="570807"/>
           </a:xfrm>
           <a:prstGeom prst="can">
@@ -12464,7 +12464,7 @@
         </p:nvSpPr>
         <p:spPr>
           <a:xfrm>
-            <a:off x="2835855" y="3137674"/>
+            <a:off x="2797755" y="3137674"/>
             <a:ext cx="1609724" cy="1303020"/>
           </a:xfrm>
           <a:prstGeom prst="verticalScroll">
@@ -12548,7 +12548,7 @@
         </p:nvSpPr>
         <p:spPr>
           <a:xfrm>
-            <a:off x="2130034" y="1223111"/>
+            <a:off x="2091934" y="1223111"/>
             <a:ext cx="2237448" cy="184666"/>
           </a:xfrm>
           <a:prstGeom prst="rect">
@@ -12583,7 +12583,7 @@
         </p:nvSpPr>
         <p:spPr>
           <a:xfrm>
-            <a:off x="2710249" y="1887033"/>
+            <a:off x="2672149" y="1887033"/>
             <a:ext cx="638710" cy="419100"/>
           </a:xfrm>
           <a:prstGeom prst="rect">
@@ -12633,7 +12633,7 @@
         </p:nvSpPr>
         <p:spPr>
           <a:xfrm>
-            <a:off x="2901007" y="2140916"/>
+            <a:off x="2862907" y="2140916"/>
             <a:ext cx="638710" cy="419100"/>
           </a:xfrm>
           <a:prstGeom prst="rect">
@@ -12683,7 +12683,7 @@
         </p:nvSpPr>
         <p:spPr>
           <a:xfrm>
-            <a:off x="3506326" y="2226302"/>
+            <a:off x="3468226" y="2226302"/>
             <a:ext cx="638710" cy="419100"/>
           </a:xfrm>
           <a:prstGeom prst="rect">
@@ -12733,7 +12733,7 @@
         </p:nvSpPr>
         <p:spPr>
           <a:xfrm>
-            <a:off x="583723" y="2107215"/>
+            <a:off x="545623" y="2107215"/>
             <a:ext cx="1534230" cy="570807"/>
           </a:xfrm>
           <a:prstGeom prst="can">
@@ -12786,7 +12786,7 @@
         </p:nvSpPr>
         <p:spPr>
           <a:xfrm>
-            <a:off x="3243858" y="1259521"/>
+            <a:off x="3205758" y="1259521"/>
             <a:ext cx="638710" cy="419100"/>
           </a:xfrm>
           <a:prstGeom prst="rect">
@@ -12839,7 +12839,7 @@
         </p:nvSpPr>
         <p:spPr>
           <a:xfrm>
-            <a:off x="103302" y="3043901"/>
+            <a:off x="65202" y="3043901"/>
             <a:ext cx="3199108" cy="2492990"/>
           </a:xfrm>
           <a:prstGeom prst="rect">
@@ -12994,7 +12994,7 @@
         </p:nvSpPr>
         <p:spPr>
           <a:xfrm>
-            <a:off x="5935125" y="860720"/>
+            <a:off x="5897025" y="860720"/>
             <a:ext cx="3199108" cy="2492990"/>
           </a:xfrm>
           <a:prstGeom prst="rect">
@@ -13172,7 +13172,7 @@
         </p:nvSpPr>
         <p:spPr>
           <a:xfrm>
-            <a:off x="4335571" y="3886841"/>
+            <a:off x="4297471" y="3886841"/>
             <a:ext cx="3199108" cy="2492990"/>
           </a:xfrm>
           <a:prstGeom prst="rect">
@@ -13305,7 +13305,7 @@
         </p:nvSpPr>
         <p:spPr>
           <a:xfrm>
-            <a:off x="1033125" y="500929"/>
+            <a:off x="995025" y="500929"/>
             <a:ext cx="638710" cy="419100"/>
           </a:xfrm>
           <a:prstGeom prst="rect">
@@ -13367,7 +13367,7 @@
         </p:blipFill>
         <p:spPr>
           <a:xfrm>
-            <a:off x="1094259" y="565351"/>
+            <a:off x="1056159" y="565351"/>
             <a:ext cx="166165" cy="174914"/>
           </a:xfrm>
           <a:prstGeom prst="rect">
@@ -13393,7 +13393,7 @@
         </p:nvCxnSpPr>
         <p:spPr>
           <a:xfrm rot="16200000" flipH="1">
-            <a:off x="2288100" y="-15592"/>
+            <a:off x="2250000" y="-15592"/>
             <a:ext cx="339492" cy="2210733"/>
           </a:xfrm>
           <a:prstGeom prst="curvedConnector3">
@@ -13441,7 +13441,7 @@
         </p:nvCxnSpPr>
         <p:spPr>
           <a:xfrm rot="16200000" flipH="1">
-            <a:off x="3452169" y="1789664"/>
+            <a:off x="3414069" y="1789664"/>
             <a:ext cx="293798" cy="71711"/>
           </a:xfrm>
           <a:prstGeom prst="curvedConnector3">
@@ -13489,7 +13489,7 @@
         </p:nvCxnSpPr>
         <p:spPr>
           <a:xfrm flipV="1">
-            <a:off x="2117953" y="2181969"/>
+            <a:off x="2079853" y="2181969"/>
             <a:ext cx="1197616" cy="210650"/>
           </a:xfrm>
           <a:prstGeom prst="curvedConnector3">
@@ -13538,7 +13538,7 @@
         </p:nvCxnSpPr>
         <p:spPr>
           <a:xfrm rot="10800000">
-            <a:off x="1350839" y="2107215"/>
+            <a:off x="1312739" y="2107215"/>
             <a:ext cx="1964731" cy="74754"/>
           </a:xfrm>
           <a:prstGeom prst="curvedConnector4">
@@ -13583,7 +13583,7 @@
         </p:nvSpPr>
         <p:spPr>
           <a:xfrm>
-            <a:off x="3315569" y="1972419"/>
+            <a:off x="3277469" y="1972419"/>
             <a:ext cx="638710" cy="419100"/>
           </a:xfrm>
           <a:prstGeom prst="rect">
@@ -13639,7 +13639,7 @@
         </p:nvCxnSpPr>
         <p:spPr>
           <a:xfrm rot="10800000">
-            <a:off x="3954278" y="2173317"/>
+            <a:off x="3916178" y="2173317"/>
             <a:ext cx="446846" cy="184328"/>
           </a:xfrm>
           <a:prstGeom prst="curvedConnector3">
@@ -13688,7 +13688,7 @@
         </p:nvCxnSpPr>
         <p:spPr>
           <a:xfrm flipV="1">
-            <a:off x="3954279" y="2072241"/>
+            <a:off x="3916179" y="2072241"/>
             <a:ext cx="1213960" cy="109728"/>
           </a:xfrm>
           <a:prstGeom prst="curvedConnector4">
@@ -13736,7 +13736,7 @@
         </p:nvCxnSpPr>
         <p:spPr>
           <a:xfrm rot="16200000" flipH="1">
-            <a:off x="3408036" y="2618407"/>
+            <a:off x="3369936" y="2618407"/>
             <a:ext cx="746155" cy="292378"/>
           </a:xfrm>
           <a:prstGeom prst="curvedConnector3">
@@ -13780,7 +13780,7 @@
         </p:nvCxnSpPr>
         <p:spPr>
           <a:xfrm>
-            <a:off x="8887432" y="3898363"/>
+            <a:off x="8849332" y="3898363"/>
             <a:ext cx="3304568" cy="1468092"/>
           </a:xfrm>
           <a:prstGeom prst="bentConnector3">
@@ -13828,7 +13828,7 @@
         </p:nvCxnSpPr>
         <p:spPr>
           <a:xfrm>
-            <a:off x="8887432" y="3807202"/>
+            <a:off x="8849332" y="3807202"/>
             <a:ext cx="3304568" cy="1559253"/>
           </a:xfrm>
           <a:prstGeom prst="bentConnector3">
@@ -13877,7 +13877,7 @@
         </p:nvCxnSpPr>
         <p:spPr>
           <a:xfrm rot="10800000" flipH="1" flipV="1">
-            <a:off x="4282702" y="3789183"/>
+            <a:off x="4244602" y="3789183"/>
             <a:ext cx="4604730" cy="524235"/>
           </a:xfrm>
           <a:prstGeom prst="curvedConnector5">
@@ -13923,7 +13923,7 @@
         </p:nvSpPr>
         <p:spPr>
           <a:xfrm>
-            <a:off x="5798333" y="3595831"/>
+            <a:off x="5760233" y="3595831"/>
             <a:ext cx="1890196" cy="276999"/>
           </a:xfrm>
           <a:prstGeom prst="rect">
@@ -13959,7 +13959,7 @@
         </p:nvSpPr>
         <p:spPr>
           <a:xfrm>
-            <a:off x="9904032" y="4399667"/>
+            <a:off x="9865932" y="4399667"/>
             <a:ext cx="1437623" cy="374321"/>
           </a:xfrm>
           <a:prstGeom prst="roundRect">

</xml_diff>